<commit_message>
Fix YAML formatting on slides 5 and 6
Split YAML code blocks into one line per paragraph so they no longer
wrap into a single run, normalize to 2-space indentation, nest steps
under agent in the lock file example, and tighten line spacing to fit.

Co-authored-by: Copilot <223556219+Copilot@users.noreply.github.com>
</commit_message>
<xml_diff>
--- a/agentic-workflows-101.pptx
+++ b/agentic-workflows-101.pptx
@@ -12131,7 +12131,7 @@
           <a:p>
             <a:pPr marL="0" indent="0" algn="l">
               <a:lnSpc>
-                <a:spcPct val="155000"/>
+                <a:spcPct val="130000"/>
               </a:lnSpc>
               <a:buNone/>
             </a:pPr>
@@ -12144,8 +12144,17 @@
                 <a:ea typeface="Consolas" pitchFamily="34" charset="-122"/>
                 <a:cs typeface="Consolas" pitchFamily="34" charset="-120"/>
               </a:rPr>
-              <a:t>--- </a:t>
-            </a:r>
+              <a:t>---</a:t>
+            </a:r>
+            <a:endParaRPr lang="en-US" sz="1950" dirty="0"/>
+          </a:p>
+          <a:p>
+            <a:pPr marL="0" indent="0" algn="l">
+              <a:lnSpc>
+                <a:spcPct val="130000"/>
+              </a:lnSpc>
+              <a:buNone/>
+            </a:pPr>
             <a:r>
               <a:rPr lang="en-US" sz="1950" dirty="0">
                 <a:solidFill>
@@ -12155,8 +12164,17 @@
                 <a:ea typeface="Consolas" pitchFamily="34" charset="-122"/>
                 <a:cs typeface="Consolas" pitchFamily="34" charset="-120"/>
               </a:rPr>
-              <a:t>on: </a:t>
-            </a:r>
+              <a:t>on:</a:t>
+            </a:r>
+            <a:endParaRPr lang="en-US" sz="1950" dirty="0"/>
+          </a:p>
+          <a:p>
+            <a:pPr marL="0" indent="0" algn="l">
+              <a:lnSpc>
+                <a:spcPct val="130000"/>
+              </a:lnSpc>
+              <a:buNone/>
+            </a:pPr>
             <a:r>
               <a:rPr lang="en-US" sz="1950" dirty="0">
                 <a:solidFill>
@@ -12166,7 +12184,7 @@
                 <a:ea typeface="Consolas" pitchFamily="34" charset="-122"/>
                 <a:cs typeface="Consolas" pitchFamily="34" charset="-120"/>
               </a:rPr>
-              <a:t>   </a:t>
+              <a:t>  </a:t>
             </a:r>
             <a:r>
               <a:rPr lang="en-US" sz="1950" dirty="0">
@@ -12177,8 +12195,17 @@
                 <a:ea typeface="Consolas" pitchFamily="34" charset="-122"/>
                 <a:cs typeface="Consolas" pitchFamily="34" charset="-120"/>
               </a:rPr>
-              <a:t>issues: </a:t>
-            </a:r>
+              <a:t>issues:</a:t>
+            </a:r>
+            <a:endParaRPr lang="en-US" sz="1950" dirty="0"/>
+          </a:p>
+          <a:p>
+            <a:pPr marL="0" indent="0" algn="l">
+              <a:lnSpc>
+                <a:spcPct val="130000"/>
+              </a:lnSpc>
+              <a:buNone/>
+            </a:pPr>
             <a:r>
               <a:rPr lang="en-US" sz="1950" dirty="0">
                 <a:solidFill>
@@ -12188,7 +12215,7 @@
                 <a:ea typeface="Consolas" pitchFamily="34" charset="-122"/>
                 <a:cs typeface="Consolas" pitchFamily="34" charset="-120"/>
               </a:rPr>
-              <a:t>     </a:t>
+              <a:t>    </a:t>
             </a:r>
             <a:r>
               <a:rPr lang="en-US" sz="1950" dirty="0">
@@ -12221,8 +12248,17 @@
                 <a:ea typeface="Consolas" pitchFamily="34" charset="-122"/>
                 <a:cs typeface="Consolas" pitchFamily="34" charset="-120"/>
               </a:rPr>
-              <a:t>[opened] </a:t>
-            </a:r>
+              <a:t>[opened]</a:t>
+            </a:r>
+            <a:endParaRPr lang="en-US" sz="1950" dirty="0"/>
+          </a:p>
+          <a:p>
+            <a:pPr marL="0" indent="0" algn="l">
+              <a:lnSpc>
+                <a:spcPct val="130000"/>
+              </a:lnSpc>
+              <a:buNone/>
+            </a:pPr>
             <a:r>
               <a:rPr lang="en-US" sz="1950" dirty="0">
                 <a:solidFill>
@@ -12243,8 +12279,17 @@
                 <a:ea typeface="Consolas" pitchFamily="34" charset="-122"/>
                 <a:cs typeface="Consolas" pitchFamily="34" charset="-120"/>
               </a:rPr>
-              <a:t> copilot </a:t>
-            </a:r>
+              <a:t> copilot</a:t>
+            </a:r>
+            <a:endParaRPr lang="en-US" sz="1950" dirty="0"/>
+          </a:p>
+          <a:p>
+            <a:pPr marL="0" indent="0" algn="l">
+              <a:lnSpc>
+                <a:spcPct val="130000"/>
+              </a:lnSpc>
+              <a:buNone/>
+            </a:pPr>
             <a:r>
               <a:rPr lang="en-US" sz="1950" dirty="0">
                 <a:solidFill>
@@ -12254,8 +12299,17 @@
                 <a:ea typeface="Consolas" pitchFamily="34" charset="-122"/>
                 <a:cs typeface="Consolas" pitchFamily="34" charset="-120"/>
               </a:rPr>
-              <a:t>permissions: </a:t>
-            </a:r>
+              <a:t>permissions:</a:t>
+            </a:r>
+            <a:endParaRPr lang="en-US" sz="1950" dirty="0"/>
+          </a:p>
+          <a:p>
+            <a:pPr marL="0" indent="0" algn="l">
+              <a:lnSpc>
+                <a:spcPct val="130000"/>
+              </a:lnSpc>
+              <a:buNone/>
+            </a:pPr>
             <a:r>
               <a:rPr lang="en-US" sz="1950" dirty="0">
                 <a:solidFill>
@@ -12265,7 +12319,7 @@
                 <a:ea typeface="Consolas" pitchFamily="34" charset="-122"/>
                 <a:cs typeface="Consolas" pitchFamily="34" charset="-120"/>
               </a:rPr>
-              <a:t>   </a:t>
+              <a:t>  </a:t>
             </a:r>
             <a:r>
               <a:rPr lang="en-US" sz="1950" dirty="0">
@@ -12298,8 +12352,17 @@
                 <a:ea typeface="Consolas" pitchFamily="34" charset="-122"/>
                 <a:cs typeface="Consolas" pitchFamily="34" charset="-120"/>
               </a:rPr>
-              <a:t>read </a:t>
-            </a:r>
+              <a:t>read</a:t>
+            </a:r>
+            <a:endParaRPr lang="en-US" sz="1950" dirty="0"/>
+          </a:p>
+          <a:p>
+            <a:pPr marL="0" indent="0" algn="l">
+              <a:lnSpc>
+                <a:spcPct val="130000"/>
+              </a:lnSpc>
+              <a:buNone/>
+            </a:pPr>
             <a:r>
               <a:rPr lang="en-US" sz="1950" dirty="0">
                 <a:solidFill>
@@ -12309,7 +12372,7 @@
                 <a:ea typeface="Consolas" pitchFamily="34" charset="-122"/>
                 <a:cs typeface="Consolas" pitchFamily="34" charset="-120"/>
               </a:rPr>
-              <a:t>   </a:t>
+              <a:t>  </a:t>
             </a:r>
             <a:r>
               <a:rPr lang="en-US" sz="1950" dirty="0">
@@ -12342,8 +12405,17 @@
                 <a:ea typeface="Consolas" pitchFamily="34" charset="-122"/>
                 <a:cs typeface="Consolas" pitchFamily="34" charset="-120"/>
               </a:rPr>
-              <a:t>read </a:t>
-            </a:r>
+              <a:t>read</a:t>
+            </a:r>
+            <a:endParaRPr lang="en-US" sz="1950" dirty="0"/>
+          </a:p>
+          <a:p>
+            <a:pPr marL="0" indent="0" algn="l">
+              <a:lnSpc>
+                <a:spcPct val="130000"/>
+              </a:lnSpc>
+              <a:buNone/>
+            </a:pPr>
             <a:r>
               <a:rPr lang="en-US" sz="1950" dirty="0">
                 <a:solidFill>
@@ -12353,8 +12425,17 @@
                 <a:ea typeface="Consolas" pitchFamily="34" charset="-122"/>
                 <a:cs typeface="Consolas" pitchFamily="34" charset="-120"/>
               </a:rPr>
-              <a:t>safe-outputs: </a:t>
-            </a:r>
+              <a:t>safe-outputs:</a:t>
+            </a:r>
+            <a:endParaRPr lang="en-US" sz="1950" dirty="0"/>
+          </a:p>
+          <a:p>
+            <a:pPr marL="0" indent="0" algn="l">
+              <a:lnSpc>
+                <a:spcPct val="130000"/>
+              </a:lnSpc>
+              <a:buNone/>
+            </a:pPr>
             <a:r>
               <a:rPr lang="en-US" sz="1950" dirty="0">
                 <a:solidFill>
@@ -12371,7 +12452,7 @@
           <a:p>
             <a:pPr marL="0" indent="0" algn="l">
               <a:lnSpc>
-                <a:spcPct val="155000"/>
+                <a:spcPct val="130000"/>
               </a:lnSpc>
               <a:buNone/>
             </a:pPr>
@@ -12384,14 +12465,14 @@
                 <a:ea typeface="Consolas" pitchFamily="34" charset="-122"/>
                 <a:cs typeface="Consolas" pitchFamily="34" charset="-120"/>
               </a:rPr>
-              <a:t>  add-labels: </a:t>
+              <a:t>  add-labels:</a:t>
             </a:r>
             <a:endParaRPr lang="en-US" sz="1950" dirty="0"/>
           </a:p>
           <a:p>
             <a:pPr marL="0" indent="0" algn="l">
               <a:lnSpc>
-                <a:spcPct val="155000"/>
+                <a:spcPct val="130000"/>
               </a:lnSpc>
               <a:buNone/>
             </a:pPr>
@@ -13305,7 +13386,7 @@
                 <a:ea typeface="Consolas" pitchFamily="34" charset="-122"/>
                 <a:cs typeface="Consolas" pitchFamily="34" charset="-120"/>
               </a:rPr>
-              <a:t>--- </a:t>
+              <a:t>---</a:t>
             </a:r>
             <a:endParaRPr lang="en-US" sz="1800" dirty="0"/>
           </a:p>
@@ -13325,8 +13406,17 @@
                 <a:ea typeface="Consolas" pitchFamily="34" charset="-122"/>
                 <a:cs typeface="Consolas" pitchFamily="34" charset="-120"/>
               </a:rPr>
-              <a:t>## Triage incoming issue </a:t>
-            </a:r>
+              <a:t>## Triage incoming issue</a:t>
+            </a:r>
+            <a:endParaRPr lang="en-US" sz="1800" dirty="0"/>
+          </a:p>
+          <a:p>
+            <a:pPr marL="0" indent="0" algn="l">
+              <a:lnSpc>
+                <a:spcPct val="155000"/>
+              </a:lnSpc>
+              <a:buNone/>
+            </a:pPr>
             <a:r>
               <a:rPr lang="en-US" sz="1800" dirty="0">
                 <a:solidFill>
@@ -13761,7 +13851,7 @@
           <a:p>
             <a:pPr marL="0" indent="0" algn="l">
               <a:lnSpc>
-                <a:spcPct val="155000"/>
+                <a:spcPct val="130000"/>
               </a:lnSpc>
               <a:buNone/>
             </a:pPr>
@@ -13785,8 +13875,17 @@
                 <a:ea typeface="Consolas" pitchFamily="34" charset="-122"/>
                 <a:cs typeface="Consolas" pitchFamily="34" charset="-120"/>
               </a:rPr>
-              <a:t> triage </a:t>
-            </a:r>
+              <a:t> triage</a:t>
+            </a:r>
+            <a:endParaRPr lang="en-US" sz="1800" dirty="0"/>
+          </a:p>
+          <a:p>
+            <a:pPr marL="0" indent="0" algn="l">
+              <a:lnSpc>
+                <a:spcPct val="130000"/>
+              </a:lnSpc>
+              <a:buNone/>
+            </a:pPr>
             <a:r>
               <a:rPr lang="en-US" sz="1800" dirty="0">
                 <a:solidFill>
@@ -13796,8 +13895,17 @@
                 <a:ea typeface="Consolas" pitchFamily="34" charset="-122"/>
                 <a:cs typeface="Consolas" pitchFamily="34" charset="-120"/>
               </a:rPr>
-              <a:t>on: </a:t>
-            </a:r>
+              <a:t>on:</a:t>
+            </a:r>
+            <a:endParaRPr lang="en-US" sz="1800" dirty="0"/>
+          </a:p>
+          <a:p>
+            <a:pPr marL="0" indent="0" algn="l">
+              <a:lnSpc>
+                <a:spcPct val="130000"/>
+              </a:lnSpc>
+              <a:buNone/>
+            </a:pPr>
             <a:r>
               <a:rPr lang="en-US" sz="1800" dirty="0">
                 <a:solidFill>
@@ -13807,7 +13915,7 @@
                 <a:ea typeface="Consolas" pitchFamily="34" charset="-122"/>
                 <a:cs typeface="Consolas" pitchFamily="34" charset="-120"/>
               </a:rPr>
-              <a:t>   </a:t>
+              <a:t>  </a:t>
             </a:r>
             <a:r>
               <a:rPr lang="en-US" sz="1800" dirty="0">
@@ -13818,8 +13926,17 @@
                 <a:ea typeface="Consolas" pitchFamily="34" charset="-122"/>
                 <a:cs typeface="Consolas" pitchFamily="34" charset="-120"/>
               </a:rPr>
-              <a:t>issues: </a:t>
-            </a:r>
+              <a:t>issues:</a:t>
+            </a:r>
+            <a:endParaRPr lang="en-US" sz="1800" dirty="0"/>
+          </a:p>
+          <a:p>
+            <a:pPr marL="0" indent="0" algn="l">
+              <a:lnSpc>
+                <a:spcPct val="130000"/>
+              </a:lnSpc>
+              <a:buNone/>
+            </a:pPr>
             <a:r>
               <a:rPr lang="en-US" sz="1800" dirty="0">
                 <a:solidFill>
@@ -13829,7 +13946,7 @@
                 <a:ea typeface="Consolas" pitchFamily="34" charset="-122"/>
                 <a:cs typeface="Consolas" pitchFamily="34" charset="-120"/>
               </a:rPr>
-              <a:t>     </a:t>
+              <a:t>    </a:t>
             </a:r>
             <a:r>
               <a:rPr lang="en-US" sz="1800" dirty="0">
@@ -13862,8 +13979,17 @@
                 <a:ea typeface="Consolas" pitchFamily="34" charset="-122"/>
                 <a:cs typeface="Consolas" pitchFamily="34" charset="-120"/>
               </a:rPr>
-              <a:t>[opened] </a:t>
-            </a:r>
+              <a:t>[opened]</a:t>
+            </a:r>
+            <a:endParaRPr lang="en-US" sz="1800" dirty="0"/>
+          </a:p>
+          <a:p>
+            <a:pPr marL="0" indent="0" algn="l">
+              <a:lnSpc>
+                <a:spcPct val="130000"/>
+              </a:lnSpc>
+              <a:buNone/>
+            </a:pPr>
             <a:r>
               <a:rPr lang="en-US" sz="1800" dirty="0">
                 <a:solidFill>
@@ -13873,8 +13999,17 @@
                 <a:ea typeface="Consolas" pitchFamily="34" charset="-122"/>
                 <a:cs typeface="Consolas" pitchFamily="34" charset="-120"/>
               </a:rPr>
-              <a:t>jobs: </a:t>
-            </a:r>
+              <a:t>jobs:</a:t>
+            </a:r>
+            <a:endParaRPr lang="en-US" sz="1800" dirty="0"/>
+          </a:p>
+          <a:p>
+            <a:pPr marL="0" indent="0" algn="l">
+              <a:lnSpc>
+                <a:spcPct val="130000"/>
+              </a:lnSpc>
+              <a:buNone/>
+            </a:pPr>
             <a:r>
               <a:rPr lang="en-US" sz="1800" dirty="0">
                 <a:solidFill>
@@ -13884,7 +14019,7 @@
                 <a:ea typeface="Consolas" pitchFamily="34" charset="-122"/>
                 <a:cs typeface="Consolas" pitchFamily="34" charset="-120"/>
               </a:rPr>
-              <a:t>   </a:t>
+              <a:t>  </a:t>
             </a:r>
             <a:r>
               <a:rPr lang="en-US" sz="1800" dirty="0">
@@ -13895,8 +14030,17 @@
                 <a:ea typeface="Consolas" pitchFamily="34" charset="-122"/>
                 <a:cs typeface="Consolas" pitchFamily="34" charset="-120"/>
               </a:rPr>
-              <a:t>agent: </a:t>
-            </a:r>
+              <a:t>agent:</a:t>
+            </a:r>
+            <a:endParaRPr lang="en-US" sz="1800" dirty="0"/>
+          </a:p>
+          <a:p>
+            <a:pPr marL="0" indent="0" algn="l">
+              <a:lnSpc>
+                <a:spcPct val="130000"/>
+              </a:lnSpc>
+              <a:buNone/>
+            </a:pPr>
             <a:r>
               <a:rPr lang="en-US" sz="1800" dirty="0">
                 <a:solidFill>
@@ -13906,7 +14050,7 @@
                 <a:ea typeface="Consolas" pitchFamily="34" charset="-122"/>
                 <a:cs typeface="Consolas" pitchFamily="34" charset="-120"/>
               </a:rPr>
-              <a:t>     </a:t>
+              <a:t>    </a:t>
             </a:r>
             <a:r>
               <a:rPr lang="en-US" sz="1800" dirty="0">
@@ -13939,8 +14083,17 @@
                 <a:ea typeface="Consolas" pitchFamily="34" charset="-122"/>
                 <a:cs typeface="Consolas" pitchFamily="34" charset="-120"/>
               </a:rPr>
-              <a:t>ubuntu-latest </a:t>
-            </a:r>
+              <a:t>ubuntu-latest</a:t>
+            </a:r>
+            <a:endParaRPr lang="en-US" sz="1800" dirty="0"/>
+          </a:p>
+          <a:p>
+            <a:pPr marL="0" indent="0" algn="l">
+              <a:lnSpc>
+                <a:spcPct val="130000"/>
+              </a:lnSpc>
+              <a:buNone/>
+            </a:pPr>
             <a:r>
               <a:rPr lang="en-US" sz="1800" dirty="0">
                 <a:solidFill>
@@ -13950,7 +14103,7 @@
                 <a:ea typeface="Consolas" pitchFamily="34" charset="-122"/>
                 <a:cs typeface="Consolas" pitchFamily="34" charset="-120"/>
               </a:rPr>
-              <a:t>     </a:t>
+              <a:t>    </a:t>
             </a:r>
             <a:r>
               <a:rPr lang="en-US" sz="1800" dirty="0">
@@ -13961,8 +14114,17 @@
                 <a:ea typeface="Consolas" pitchFamily="34" charset="-122"/>
                 <a:cs typeface="Consolas" pitchFamily="34" charset="-120"/>
               </a:rPr>
-              <a:t>permissions: </a:t>
-            </a:r>
+              <a:t>permissions:</a:t>
+            </a:r>
+            <a:endParaRPr lang="en-US" sz="1800" dirty="0"/>
+          </a:p>
+          <a:p>
+            <a:pPr marL="0" indent="0" algn="l">
+              <a:lnSpc>
+                <a:spcPct val="130000"/>
+              </a:lnSpc>
+              <a:buNone/>
+            </a:pPr>
             <a:r>
               <a:rPr lang="en-US" sz="1800" dirty="0">
                 <a:solidFill>
@@ -13972,7 +14134,7 @@
                 <a:ea typeface="Consolas" pitchFamily="34" charset="-122"/>
                 <a:cs typeface="Consolas" pitchFamily="34" charset="-120"/>
               </a:rPr>
-              <a:t>       </a:t>
+              <a:t>      </a:t>
             </a:r>
             <a:r>
               <a:rPr lang="en-US" sz="1800" dirty="0">
@@ -14005,8 +14167,17 @@
                 <a:ea typeface="Consolas" pitchFamily="34" charset="-122"/>
                 <a:cs typeface="Consolas" pitchFamily="34" charset="-120"/>
               </a:rPr>
-              <a:t>read </a:t>
-            </a:r>
+              <a:t>read</a:t>
+            </a:r>
+            <a:endParaRPr lang="en-US" sz="1800" dirty="0"/>
+          </a:p>
+          <a:p>
+            <a:pPr marL="0" indent="0" algn="l">
+              <a:lnSpc>
+                <a:spcPct val="130000"/>
+              </a:lnSpc>
+              <a:buNone/>
+            </a:pPr>
             <a:r>
               <a:rPr lang="en-US" sz="1800" dirty="0">
                 <a:solidFill>
@@ -14016,7 +14187,7 @@
                 <a:ea typeface="Consolas" pitchFamily="34" charset="-122"/>
                 <a:cs typeface="Consolas" pitchFamily="34" charset="-120"/>
               </a:rPr>
-              <a:t>       </a:t>
+              <a:t>    </a:t>
             </a:r>
             <a:r>
               <a:rPr lang="en-US" sz="1800" dirty="0">
@@ -14027,8 +14198,17 @@
                 <a:ea typeface="Consolas" pitchFamily="34" charset="-122"/>
                 <a:cs typeface="Consolas" pitchFamily="34" charset="-120"/>
               </a:rPr>
-              <a:t>steps: </a:t>
-            </a:r>
+              <a:t>steps:</a:t>
+            </a:r>
+            <a:endParaRPr lang="en-US" sz="1800" dirty="0"/>
+          </a:p>
+          <a:p>
+            <a:pPr marL="0" indent="0" algn="l">
+              <a:lnSpc>
+                <a:spcPct val="130000"/>
+              </a:lnSpc>
+              <a:buNone/>
+            </a:pPr>
             <a:r>
               <a:rPr lang="en-US" sz="1800" dirty="0">
                 <a:solidFill>
@@ -14038,7 +14218,7 @@
                 <a:ea typeface="Consolas" pitchFamily="34" charset="-122"/>
                 <a:cs typeface="Consolas" pitchFamily="34" charset="-120"/>
               </a:rPr>
-              <a:t>        -  </a:t>
+              <a:t>      - </a:t>
             </a:r>
             <a:r>
               <a:rPr lang="en-US" sz="1800" dirty="0">

</xml_diff>